<commit_message>
EVM1110E: đối chiếu nguyên văn Luật Báo chí 2025, Luật QC 75/2025; thêm Larson & Wikström 2001; gỡ VERIFY CVP ở Buổi 5
Co-Authored-By: Claude Opus 5.5 <noreply@anthropic.com>
Claude-Session: https://claude.ai/code/session_014QwQ68qeN46CsLnynfoTqG
</commit_message>
<xml_diff>
--- a/courses/EVM1110E/slides/W05_slides.pptx
+++ b/courses/EVM1110E/slides/W05_slides.pptx
@@ -3540,7 +3540,7 @@
             <a:r>
               <a:rPr lang="en-US" dirty="0"/>
               <a:t>Nói: Anderson, Narus và van Rossum, 2006, trên Harvard Business Review: không có sự thống nhất CVP là gì; phần lớn CVP tuyên bố tiết kiệm và lợi ích mà không chứng minh, nên khách hàng coi là “marketing puffery” — quảng cáo thổi phồng. Họ chia ba kiểu. All benefits: liệt kê mọi lợi ích — dễ hứa điều không có thật với khách hàng này. Favorable points of difference: điểm khác biệt có lợi so với đối thủ — nhưng khác biệt chưa chắc có giá trị với khách hàng này. Resonating focus — trọng tâm cộng hưởng: một hai điểm khác biệt tạo giá trị lớn nhất cho khách hàng. Kiểu thứ ba cần hiểu sâu khách hàng — và đó là kiểu nên dùng.
-(GV: E02 — đã đọc phần mở đầu trên HBR; nội dung ba kiểu theo nguồn thứ cấp [VERIFY]. Hồ sơ năng lực ở slide 2 là kiểu “all benefits” (đáp án bước 1 của Thực hành 1).)
+(GV: E02 — đã đối chiếu bản đầy đủ (HBR reprint R0603F, tr.2–3 bản reprint): ba kiểu all benefits / favorable points of difference / resonating focus; bài còn phân biệt points of parity, points of difference, points of contention. Hồ sơ năng lực ở slide 2 là kiểu “all benefits” (đáp án bước 1 của Thực hành 1).)
 Hỏi lớp: —
 Chuyển ý: Một CVP tốt có ba phần.</a:t>
             </a:r>
@@ -24566,7 +24566,7 @@
                 <a:ea typeface="Alexandria" pitchFamily="34" charset="-122"/>
                 <a:cs typeface="Alexandria" pitchFamily="34" charset="-120"/>
               </a:rPr>
-              <a:t>Nguồn: Anderson, Narus &amp; van Rossum (2006), HBR — khách hàng coi nhiều CVP là “marketing puffery”. [VERIFY: ba kiểu CVP — đọc qua nguồn thứ cấp]</a:t>
+              <a:t>Nguồn: Anderson, Narus &amp; van Rossum (2006), HBR 84(3) — exhibit “Which Alternative Conveys Value to Customers?”; khách hàng coi nhiều CVP là “marketing puffery”.</a:t>
             </a:r>
             <a:endParaRPr lang="en-US" sz="1200" dirty="0"/>
           </a:p>

</xml_diff>